<commit_message>
About page updates: full names, new icons, copy refinements
</commit_message>
<xml_diff>
--- a/IOC/island_capital_IOC_chart .pptx
+++ b/IOC/island_capital_IOC_chart .pptx
@@ -5,10 +5,11 @@
     <p:sldMasterId id="2147483648" r:id="rId1"/>
   </p:sldMasterIdLst>
   <p:notesMasterIdLst>
-    <p:notesMasterId r:id="rId3"/>
+    <p:notesMasterId r:id="rId4"/>
   </p:notesMasterIdLst>
   <p:sldIdLst>
     <p:sldId id="258" r:id="rId2"/>
+    <p:sldId id="259" r:id="rId3"/>
   </p:sldIdLst>
   <p:sldSz cx="12192000" cy="6858000"/>
   <p:notesSz cx="6858000" cy="12192000"/>
@@ -123,43 +124,211 @@
 </p:presentation>
 </file>
 
+<file path=ppt/revisionInfo.xml><?xml version="1.0" encoding="utf-8"?>
+<p1510:revInfo xmlns:a="http://schemas.openxmlformats.org/drawingml/2006/main" xmlns:r="http://schemas.openxmlformats.org/officeDocument/2006/relationships" xmlns:p1510="http://schemas.microsoft.com/office/powerpoint/2015/10/main">
+  <p1510:revLst>
+    <p1510:client id="{BBF6E112-077A-4D03-A7D6-4A7E25FD1D3B}" v="284" dt="2026-04-01T10:42:39.749"/>
+  </p1510:revLst>
+</p1510:revInfo>
+</file>
+
 <file path=ppt/changesInfos/changesInfo1.xml><?xml version="1.0" encoding="utf-8"?>
 <pc:chgInfo xmlns:a="http://schemas.openxmlformats.org/drawingml/2006/main" xmlns:r="http://schemas.openxmlformats.org/officeDocument/2006/relationships" xmlns:ac="http://schemas.microsoft.com/office/drawing/2013/main/command" xmlns:pc="http://schemas.microsoft.com/office/powerpoint/2013/main/command">
   <pc:docChgLst>
     <pc:chgData name="Isa Lan" userId="945ba5853d06cfb5" providerId="LiveId" clId="{4BF6D3D9-5CF5-48F0-AB96-70EE9B74F7F8}"/>
-    <pc:docChg chg="addSld delSld modSld">
-      <pc:chgData name="Isa Lan" userId="945ba5853d06cfb5" providerId="LiveId" clId="{4BF6D3D9-5CF5-48F0-AB96-70EE9B74F7F8}" dt="2026-03-29T22:21:03.677" v="5" actId="207"/>
+    <pc:docChg chg="undo redo custSel addSld delSld modSld">
+      <pc:chgData name="Isa Lan" userId="945ba5853d06cfb5" providerId="LiveId" clId="{4BF6D3D9-5CF5-48F0-AB96-70EE9B74F7F8}" dt="2026-04-01T10:42:39.747" v="457" actId="1035"/>
       <pc:docMkLst>
         <pc:docMk/>
       </pc:docMkLst>
-      <pc:sldChg chg="modSp mod">
-        <pc:chgData name="Isa Lan" userId="945ba5853d06cfb5" providerId="LiveId" clId="{4BF6D3D9-5CF5-48F0-AB96-70EE9B74F7F8}" dt="2026-03-29T22:21:03.677" v="5" actId="207"/>
+      <pc:sldChg chg="addSp delSp modSp mod">
+        <pc:chgData name="Isa Lan" userId="945ba5853d06cfb5" providerId="LiveId" clId="{4BF6D3D9-5CF5-48F0-AB96-70EE9B74F7F8}" dt="2026-04-01T10:42:39.747" v="457" actId="1035"/>
         <pc:sldMkLst>
           <pc:docMk/>
           <pc:sldMk cId="2747055121" sldId="258"/>
         </pc:sldMkLst>
-        <pc:spChg chg="mod">
-          <ac:chgData name="Isa Lan" userId="945ba5853d06cfb5" providerId="LiveId" clId="{4BF6D3D9-5CF5-48F0-AB96-70EE9B74F7F8}" dt="2026-03-29T22:21:03.677" v="5" actId="207"/>
+        <pc:spChg chg="mod ord">
+          <ac:chgData name="Isa Lan" userId="945ba5853d06cfb5" providerId="LiveId" clId="{4BF6D3D9-5CF5-48F0-AB96-70EE9B74F7F8}" dt="2026-04-01T06:23:16.580" v="199" actId="167"/>
           <ac:spMkLst>
             <pc:docMk/>
             <pc:sldMk cId="2747055121" sldId="258"/>
             <ac:spMk id="5" creationId="{A1B4C223-9E81-6A6D-FAD9-488B502D967B}"/>
           </ac:spMkLst>
         </pc:spChg>
+        <pc:spChg chg="mod">
+          <ac:chgData name="Isa Lan" userId="945ba5853d06cfb5" providerId="LiveId" clId="{4BF6D3D9-5CF5-48F0-AB96-70EE9B74F7F8}" dt="2026-03-31T19:04:10.913" v="6" actId="14100"/>
+          <ac:spMkLst>
+            <pc:docMk/>
+            <pc:sldMk cId="2747055121" sldId="258"/>
+            <ac:spMk id="10" creationId="{6E77B96C-8EA8-A6F4-5E95-FBBBDF0F63DA}"/>
+          </ac:spMkLst>
+        </pc:spChg>
+        <pc:spChg chg="mod">
+          <ac:chgData name="Isa Lan" userId="945ba5853d06cfb5" providerId="LiveId" clId="{4BF6D3D9-5CF5-48F0-AB96-70EE9B74F7F8}" dt="2026-03-31T19:04:10.913" v="6" actId="14100"/>
+          <ac:spMkLst>
+            <pc:docMk/>
+            <pc:sldMk cId="2747055121" sldId="258"/>
+            <ac:spMk id="11" creationId="{1EABFA04-5F8D-4FCE-A878-8B111C1FAEBF}"/>
+          </ac:spMkLst>
+        </pc:spChg>
+        <pc:spChg chg="mod">
+          <ac:chgData name="Isa Lan" userId="945ba5853d06cfb5" providerId="LiveId" clId="{4BF6D3D9-5CF5-48F0-AB96-70EE9B74F7F8}" dt="2026-03-31T19:04:10.913" v="6" actId="14100"/>
+          <ac:spMkLst>
+            <pc:docMk/>
+            <pc:sldMk cId="2747055121" sldId="258"/>
+            <ac:spMk id="13" creationId="{6996C918-8F77-EC7F-CB34-11D4752BCAAE}"/>
+          </ac:spMkLst>
+        </pc:spChg>
+        <pc:spChg chg="mod">
+          <ac:chgData name="Isa Lan" userId="945ba5853d06cfb5" providerId="LiveId" clId="{4BF6D3D9-5CF5-48F0-AB96-70EE9B74F7F8}" dt="2026-03-31T19:04:10.913" v="6" actId="14100"/>
+          <ac:spMkLst>
+            <pc:docMk/>
+            <pc:sldMk cId="2747055121" sldId="258"/>
+            <ac:spMk id="15" creationId="{B3412D6D-20EC-A7DA-CA60-E5195A248D61}"/>
+          </ac:spMkLst>
+        </pc:spChg>
+        <pc:spChg chg="mod">
+          <ac:chgData name="Isa Lan" userId="945ba5853d06cfb5" providerId="LiveId" clId="{4BF6D3D9-5CF5-48F0-AB96-70EE9B74F7F8}" dt="2026-03-31T19:04:10.913" v="6" actId="14100"/>
+          <ac:spMkLst>
+            <pc:docMk/>
+            <pc:sldMk cId="2747055121" sldId="258"/>
+            <ac:spMk id="17" creationId="{83AA9F90-0D84-1DFD-5588-A4FC77F1549C}"/>
+          </ac:spMkLst>
+        </pc:spChg>
+        <pc:spChg chg="mod">
+          <ac:chgData name="Isa Lan" userId="945ba5853d06cfb5" providerId="LiveId" clId="{4BF6D3D9-5CF5-48F0-AB96-70EE9B74F7F8}" dt="2026-03-31T19:04:10.913" v="6" actId="14100"/>
+          <ac:spMkLst>
+            <pc:docMk/>
+            <pc:sldMk cId="2747055121" sldId="258"/>
+            <ac:spMk id="18" creationId="{0234C0E9-42B1-7F35-314F-FEE2DAD1EEBC}"/>
+          </ac:spMkLst>
+        </pc:spChg>
+        <pc:spChg chg="mod">
+          <ac:chgData name="Isa Lan" userId="945ba5853d06cfb5" providerId="LiveId" clId="{4BF6D3D9-5CF5-48F0-AB96-70EE9B74F7F8}" dt="2026-03-31T19:04:10.913" v="6" actId="14100"/>
+          <ac:spMkLst>
+            <pc:docMk/>
+            <pc:sldMk cId="2747055121" sldId="258"/>
+            <ac:spMk id="19" creationId="{6E387BBF-043C-1083-4B52-F1A1AFD35709}"/>
+          </ac:spMkLst>
+        </pc:spChg>
+        <pc:spChg chg="mod">
+          <ac:chgData name="Isa Lan" userId="945ba5853d06cfb5" providerId="LiveId" clId="{4BF6D3D9-5CF5-48F0-AB96-70EE9B74F7F8}" dt="2026-04-01T10:10:42.847" v="262" actId="14100"/>
+          <ac:spMkLst>
+            <pc:docMk/>
+            <pc:sldMk cId="2747055121" sldId="258"/>
+            <ac:spMk id="21" creationId="{95D89EDC-6ADF-908B-CC4E-C7CD45055E2A}"/>
+          </ac:spMkLst>
+        </pc:spChg>
+        <pc:spChg chg="mod">
+          <ac:chgData name="Isa Lan" userId="945ba5853d06cfb5" providerId="LiveId" clId="{4BF6D3D9-5CF5-48F0-AB96-70EE9B74F7F8}" dt="2026-04-01T10:11:10.653" v="263" actId="14100"/>
+          <ac:spMkLst>
+            <pc:docMk/>
+            <pc:sldMk cId="2747055121" sldId="258"/>
+            <ac:spMk id="22" creationId="{0C932C61-FD2F-3607-BEC0-25ECFF011559}"/>
+          </ac:spMkLst>
+        </pc:spChg>
+        <pc:spChg chg="mod">
+          <ac:chgData name="Isa Lan" userId="945ba5853d06cfb5" providerId="LiveId" clId="{4BF6D3D9-5CF5-48F0-AB96-70EE9B74F7F8}" dt="2026-04-01T07:32:26.968" v="253" actId="14100"/>
+          <ac:spMkLst>
+            <pc:docMk/>
+            <pc:sldMk cId="2747055121" sldId="258"/>
+            <ac:spMk id="23" creationId="{4D39A0B9-45F8-477E-3D20-44D8C29B684E}"/>
+          </ac:spMkLst>
+        </pc:spChg>
+        <pc:picChg chg="add del mod ord">
+          <ac:chgData name="Isa Lan" userId="945ba5853d06cfb5" providerId="LiveId" clId="{4BF6D3D9-5CF5-48F0-AB96-70EE9B74F7F8}" dt="2026-04-01T06:33:53.258" v="212" actId="478"/>
+          <ac:picMkLst>
+            <pc:docMk/>
+            <pc:sldMk cId="2747055121" sldId="258"/>
+            <ac:picMk id="8" creationId="{1961DE27-C96B-713E-FAB5-89200D14B587}"/>
+          </ac:picMkLst>
+        </pc:picChg>
+        <pc:picChg chg="add del mod">
+          <ac:chgData name="Isa Lan" userId="945ba5853d06cfb5" providerId="LiveId" clId="{4BF6D3D9-5CF5-48F0-AB96-70EE9B74F7F8}" dt="2026-04-01T07:38:14.657" v="260" actId="21"/>
+          <ac:picMkLst>
+            <pc:docMk/>
+            <pc:sldMk cId="2747055121" sldId="258"/>
+            <ac:picMk id="14" creationId="{E2A65885-D98A-6AC5-2504-ABC5C7D55A17}"/>
+          </ac:picMkLst>
+        </pc:picChg>
+        <pc:picChg chg="add del mod">
+          <ac:chgData name="Isa Lan" userId="945ba5853d06cfb5" providerId="LiveId" clId="{4BF6D3D9-5CF5-48F0-AB96-70EE9B74F7F8}" dt="2026-04-01T06:33:56.479" v="214" actId="478"/>
+          <ac:picMkLst>
+            <pc:docMk/>
+            <pc:sldMk cId="2747055121" sldId="258"/>
+            <ac:picMk id="1026" creationId="{A5FADEC2-3254-82F0-9AD3-EB3F86A84C29}"/>
+          </ac:picMkLst>
+        </pc:picChg>
+        <pc:picChg chg="add del mod">
+          <ac:chgData name="Isa Lan" userId="945ba5853d06cfb5" providerId="LiveId" clId="{4BF6D3D9-5CF5-48F0-AB96-70EE9B74F7F8}" dt="2026-04-01T07:32:47.970" v="256" actId="478"/>
+          <ac:picMkLst>
+            <pc:docMk/>
+            <pc:sldMk cId="2747055121" sldId="258"/>
+            <ac:picMk id="1028" creationId="{D6AE07F7-6101-5788-F7E5-4E4057BB86BA}"/>
+          </ac:picMkLst>
+        </pc:picChg>
+        <pc:picChg chg="add del mod">
+          <ac:chgData name="Isa Lan" userId="945ba5853d06cfb5" providerId="LiveId" clId="{4BF6D3D9-5CF5-48F0-AB96-70EE9B74F7F8}" dt="2026-04-01T06:33:54.518" v="213" actId="478"/>
+          <ac:picMkLst>
+            <pc:docMk/>
+            <pc:sldMk cId="2747055121" sldId="258"/>
+            <ac:picMk id="1030" creationId="{97878CF3-90E6-5BD2-F7F8-CBCDC00C090E}"/>
+          </ac:picMkLst>
+        </pc:picChg>
+        <pc:picChg chg="add del mod">
+          <ac:chgData name="Isa Lan" userId="945ba5853d06cfb5" providerId="LiveId" clId="{4BF6D3D9-5CF5-48F0-AB96-70EE9B74F7F8}" dt="2026-04-01T06:33:53.258" v="212" actId="478"/>
+          <ac:picMkLst>
+            <pc:docMk/>
+            <pc:sldMk cId="2747055121" sldId="258"/>
+            <ac:picMk id="1032" creationId="{D606DF40-B896-6F3A-FAF5-7754B9A000E8}"/>
+          </ac:picMkLst>
+        </pc:picChg>
+        <pc:picChg chg="add del mod">
+          <ac:chgData name="Isa Lan" userId="945ba5853d06cfb5" providerId="LiveId" clId="{4BF6D3D9-5CF5-48F0-AB96-70EE9B74F7F8}" dt="2026-04-01T07:29:40.666" v="235" actId="478"/>
+          <ac:picMkLst>
+            <pc:docMk/>
+            <pc:sldMk cId="2747055121" sldId="258"/>
+            <ac:picMk id="1034" creationId="{CCEC9F24-B970-8558-3951-8E6DE9DD6050}"/>
+          </ac:picMkLst>
+        </pc:picChg>
+        <pc:picChg chg="add mod">
+          <ac:chgData name="Isa Lan" userId="945ba5853d06cfb5" providerId="LiveId" clId="{4BF6D3D9-5CF5-48F0-AB96-70EE9B74F7F8}" dt="2026-04-01T10:42:39.747" v="457" actId="1035"/>
+          <ac:picMkLst>
+            <pc:docMk/>
+            <pc:sldMk cId="2747055121" sldId="258"/>
+            <ac:picMk id="1036" creationId="{AE376F89-EC41-8F46-4F3E-32837FACB90E}"/>
+          </ac:picMkLst>
+        </pc:picChg>
       </pc:sldChg>
-      <pc:sldChg chg="del">
-        <pc:chgData name="Isa Lan" userId="945ba5853d06cfb5" providerId="LiveId" clId="{4BF6D3D9-5CF5-48F0-AB96-70EE9B74F7F8}" dt="2026-03-29T22:12:27.093" v="0" actId="47"/>
+      <pc:sldChg chg="addSp modSp new">
+        <pc:chgData name="Isa Lan" userId="945ba5853d06cfb5" providerId="LiveId" clId="{4BF6D3D9-5CF5-48F0-AB96-70EE9B74F7F8}" dt="2026-04-01T07:38:17.922" v="261"/>
         <pc:sldMkLst>
           <pc:docMk/>
-          <pc:sldMk cId="1883358546" sldId="259"/>
+          <pc:sldMk cId="1209431417" sldId="259"/>
         </pc:sldMkLst>
+        <pc:picChg chg="add mod">
+          <ac:chgData name="Isa Lan" userId="945ba5853d06cfb5" providerId="LiveId" clId="{4BF6D3D9-5CF5-48F0-AB96-70EE9B74F7F8}" dt="2026-04-01T07:38:17.922" v="261"/>
+          <ac:picMkLst>
+            <pc:docMk/>
+            <pc:sldMk cId="1209431417" sldId="259"/>
+            <ac:picMk id="14" creationId="{E2A65885-D98A-6AC5-2504-ABC5C7D55A17}"/>
+          </ac:picMkLst>
+        </pc:picChg>
       </pc:sldChg>
-      <pc:sldChg chg="new del">
-        <pc:chgData name="Isa Lan" userId="945ba5853d06cfb5" providerId="LiveId" clId="{4BF6D3D9-5CF5-48F0-AB96-70EE9B74F7F8}" dt="2026-03-29T22:19:16.717" v="2" actId="47"/>
+      <pc:sldChg chg="addSp new del mod setBg">
+        <pc:chgData name="Isa Lan" userId="945ba5853d06cfb5" providerId="LiveId" clId="{4BF6D3D9-5CF5-48F0-AB96-70EE9B74F7F8}" dt="2026-04-01T07:33:04.986" v="257" actId="47"/>
         <pc:sldMkLst>
           <pc:docMk/>
-          <pc:sldMk cId="2500116224" sldId="259"/>
+          <pc:sldMk cId="3184195519" sldId="259"/>
         </pc:sldMkLst>
+        <pc:picChg chg="add">
+          <ac:chgData name="Isa Lan" userId="945ba5853d06cfb5" providerId="LiveId" clId="{4BF6D3D9-5CF5-48F0-AB96-70EE9B74F7F8}" dt="2026-04-01T06:37:18.760" v="231" actId="22"/>
+          <ac:picMkLst>
+            <pc:docMk/>
+            <pc:sldMk cId="3184195519" sldId="259"/>
+            <ac:picMk id="3" creationId="{58376668-A496-30E4-91B5-BB3E74603B78}"/>
+          </ac:picMkLst>
+        </pc:picChg>
       </pc:sldChg>
     </pc:docChg>
   </pc:docChgLst>
@@ -645,6 +814,136 @@
         </p:grpSpPr>
         <p:sp>
           <p:nvSpPr>
+            <p:cNvPr id="5" name="Freeform: Shape 4">
+              <a:extLst>
+                <a:ext uri="{FF2B5EF4-FFF2-40B4-BE49-F238E27FC236}">
+                  <a16:creationId xmlns:a16="http://schemas.microsoft.com/office/drawing/2014/main" id="{A1B4C223-9E81-6A6D-FAD9-488B502D967B}"/>
+                </a:ext>
+              </a:extLst>
+            </p:cNvPr>
+            <p:cNvSpPr/>
+            <p:nvPr/>
+          </p:nvSpPr>
+          <p:spPr>
+            <a:xfrm>
+              <a:off x="3892173" y="780048"/>
+              <a:ext cx="4620378" cy="4272501"/>
+            </a:xfrm>
+            <a:custGeom>
+              <a:avLst/>
+              <a:gdLst>
+                <a:gd name="csX0" fmla="*/ 4246775 w 4551680"/>
+                <a:gd name="csY0" fmla="*/ 3413760 h 4551680"/>
+                <a:gd name="csX1" fmla="*/ 2275840 w 4551680"/>
+                <a:gd name="csY1" fmla="*/ 4551680 h 4551680"/>
+                <a:gd name="csX2" fmla="*/ 304905 w 4551680"/>
+                <a:gd name="csY2" fmla="*/ 3413760 h 4551680"/>
+                <a:gd name="csX3" fmla="*/ 2275840 w 4551680"/>
+                <a:gd name="csY3" fmla="*/ 2275840 h 4551680"/>
+                <a:gd name="csX4" fmla="*/ 4246775 w 4551680"/>
+                <a:gd name="csY4" fmla="*/ 3413760 h 4551680"/>
+              </a:gdLst>
+              <a:ahLst/>
+              <a:cxnLst>
+                <a:cxn ang="0">
+                  <a:pos x="csX0" y="csY0"/>
+                </a:cxn>
+                <a:cxn ang="0">
+                  <a:pos x="csX1" y="csY1"/>
+                </a:cxn>
+                <a:cxn ang="0">
+                  <a:pos x="csX2" y="csY2"/>
+                </a:cxn>
+                <a:cxn ang="0">
+                  <a:pos x="csX3" y="csY3"/>
+                </a:cxn>
+                <a:cxn ang="0">
+                  <a:pos x="csX4" y="csY4"/>
+                </a:cxn>
+              </a:cxnLst>
+              <a:rect l="l" t="t" r="r" b="b"/>
+              <a:pathLst>
+                <a:path w="4551680" h="4551680">
+                  <a:moveTo>
+                    <a:pt x="4246775" y="3413760"/>
+                  </a:moveTo>
+                  <a:cubicBezTo>
+                    <a:pt x="3840235" y="4117907"/>
+                    <a:pt x="3088919" y="4551680"/>
+                    <a:pt x="2275840" y="4551680"/>
+                  </a:cubicBezTo>
+                  <a:cubicBezTo>
+                    <a:pt x="1462761" y="4551680"/>
+                    <a:pt x="711444" y="4117907"/>
+                    <a:pt x="304905" y="3413760"/>
+                  </a:cubicBezTo>
+                  <a:lnTo>
+                    <a:pt x="2275840" y="2275840"/>
+                  </a:lnTo>
+                  <a:lnTo>
+                    <a:pt x="4246775" y="3413760"/>
+                  </a:lnTo>
+                  <a:close/>
+                </a:path>
+              </a:pathLst>
+            </a:custGeom>
+            <a:solidFill>
+              <a:srgbClr val="74B32F"/>
+            </a:solidFill>
+          </p:spPr>
+          <p:style>
+            <a:lnRef idx="2">
+              <a:schemeClr val="lt1">
+                <a:hueOff val="0"/>
+                <a:satOff val="0"/>
+                <a:lumOff val="0"/>
+                <a:alphaOff val="0"/>
+              </a:schemeClr>
+            </a:lnRef>
+            <a:fillRef idx="1">
+              <a:schemeClr val="accent1">
+                <a:hueOff val="0"/>
+                <a:satOff val="0"/>
+                <a:lumOff val="0"/>
+                <a:alphaOff val="0"/>
+              </a:schemeClr>
+            </a:fillRef>
+            <a:effectRef idx="0">
+              <a:schemeClr val="accent1">
+                <a:hueOff val="0"/>
+                <a:satOff val="0"/>
+                <a:lumOff val="0"/>
+                <a:alphaOff val="0"/>
+              </a:schemeClr>
+            </a:effectRef>
+            <a:fontRef idx="minor">
+              <a:schemeClr val="lt1"/>
+            </a:fontRef>
+          </p:style>
+          <p:txBody>
+            <a:bodyPr spcFirstLastPara="0" vert="horz" wrap="square" lIns="1166284" tIns="3035723" rIns="1112096" bIns="488951" numCol="1" spcCol="1270" anchor="ctr" anchorCtr="0">
+              <a:noAutofit/>
+            </a:bodyPr>
+            <a:lstStyle/>
+            <a:p>
+              <a:pPr marL="0" lvl="0" indent="0" algn="ctr" defTabSz="2889250">
+                <a:lnSpc>
+                  <a:spcPct val="90000"/>
+                </a:lnSpc>
+                <a:spcBef>
+                  <a:spcPct val="0"/>
+                </a:spcBef>
+                <a:spcAft>
+                  <a:spcPct val="35000"/>
+                </a:spcAft>
+                <a:buNone/>
+              </a:pPr>
+              <a:endParaRPr lang="en-GB" sz="6500" kern="1200" dirty="0"/>
+            </a:p>
+          </p:txBody>
+        </p:sp>
+        <p:sp>
+          <p:nvSpPr>
             <p:cNvPr id="4" name="Freeform: Shape 3">
               <a:extLst>
                 <a:ext uri="{FF2B5EF4-FFF2-40B4-BE49-F238E27FC236}">
@@ -775,136 +1074,6 @@
         </p:sp>
         <p:sp>
           <p:nvSpPr>
-            <p:cNvPr id="5" name="Freeform: Shape 4">
-              <a:extLst>
-                <a:ext uri="{FF2B5EF4-FFF2-40B4-BE49-F238E27FC236}">
-                  <a16:creationId xmlns:a16="http://schemas.microsoft.com/office/drawing/2014/main" id="{A1B4C223-9E81-6A6D-FAD9-488B502D967B}"/>
-                </a:ext>
-              </a:extLst>
-            </p:cNvPr>
-            <p:cNvSpPr/>
-            <p:nvPr/>
-          </p:nvSpPr>
-          <p:spPr>
-            <a:xfrm>
-              <a:off x="3892173" y="780048"/>
-              <a:ext cx="4620378" cy="4272501"/>
-            </a:xfrm>
-            <a:custGeom>
-              <a:avLst/>
-              <a:gdLst>
-                <a:gd name="csX0" fmla="*/ 4246775 w 4551680"/>
-                <a:gd name="csY0" fmla="*/ 3413760 h 4551680"/>
-                <a:gd name="csX1" fmla="*/ 2275840 w 4551680"/>
-                <a:gd name="csY1" fmla="*/ 4551680 h 4551680"/>
-                <a:gd name="csX2" fmla="*/ 304905 w 4551680"/>
-                <a:gd name="csY2" fmla="*/ 3413760 h 4551680"/>
-                <a:gd name="csX3" fmla="*/ 2275840 w 4551680"/>
-                <a:gd name="csY3" fmla="*/ 2275840 h 4551680"/>
-                <a:gd name="csX4" fmla="*/ 4246775 w 4551680"/>
-                <a:gd name="csY4" fmla="*/ 3413760 h 4551680"/>
-              </a:gdLst>
-              <a:ahLst/>
-              <a:cxnLst>
-                <a:cxn ang="0">
-                  <a:pos x="csX0" y="csY0"/>
-                </a:cxn>
-                <a:cxn ang="0">
-                  <a:pos x="csX1" y="csY1"/>
-                </a:cxn>
-                <a:cxn ang="0">
-                  <a:pos x="csX2" y="csY2"/>
-                </a:cxn>
-                <a:cxn ang="0">
-                  <a:pos x="csX3" y="csY3"/>
-                </a:cxn>
-                <a:cxn ang="0">
-                  <a:pos x="csX4" y="csY4"/>
-                </a:cxn>
-              </a:cxnLst>
-              <a:rect l="l" t="t" r="r" b="b"/>
-              <a:pathLst>
-                <a:path w="4551680" h="4551680">
-                  <a:moveTo>
-                    <a:pt x="4246775" y="3413760"/>
-                  </a:moveTo>
-                  <a:cubicBezTo>
-                    <a:pt x="3840235" y="4117907"/>
-                    <a:pt x="3088919" y="4551680"/>
-                    <a:pt x="2275840" y="4551680"/>
-                  </a:cubicBezTo>
-                  <a:cubicBezTo>
-                    <a:pt x="1462761" y="4551680"/>
-                    <a:pt x="711444" y="4117907"/>
-                    <a:pt x="304905" y="3413760"/>
-                  </a:cubicBezTo>
-                  <a:lnTo>
-                    <a:pt x="2275840" y="2275840"/>
-                  </a:lnTo>
-                  <a:lnTo>
-                    <a:pt x="4246775" y="3413760"/>
-                  </a:lnTo>
-                  <a:close/>
-                </a:path>
-              </a:pathLst>
-            </a:custGeom>
-            <a:solidFill>
-              <a:srgbClr val="74B32F"/>
-            </a:solidFill>
-          </p:spPr>
-          <p:style>
-            <a:lnRef idx="2">
-              <a:schemeClr val="lt1">
-                <a:hueOff val="0"/>
-                <a:satOff val="0"/>
-                <a:lumOff val="0"/>
-                <a:alphaOff val="0"/>
-              </a:schemeClr>
-            </a:lnRef>
-            <a:fillRef idx="1">
-              <a:schemeClr val="accent1">
-                <a:hueOff val="0"/>
-                <a:satOff val="0"/>
-                <a:lumOff val="0"/>
-                <a:alphaOff val="0"/>
-              </a:schemeClr>
-            </a:fillRef>
-            <a:effectRef idx="0">
-              <a:schemeClr val="accent1">
-                <a:hueOff val="0"/>
-                <a:satOff val="0"/>
-                <a:lumOff val="0"/>
-                <a:alphaOff val="0"/>
-              </a:schemeClr>
-            </a:effectRef>
-            <a:fontRef idx="minor">
-              <a:schemeClr val="lt1"/>
-            </a:fontRef>
-          </p:style>
-          <p:txBody>
-            <a:bodyPr spcFirstLastPara="0" vert="horz" wrap="square" lIns="1166284" tIns="3035723" rIns="1112096" bIns="488951" numCol="1" spcCol="1270" anchor="ctr" anchorCtr="0">
-              <a:noAutofit/>
-            </a:bodyPr>
-            <a:lstStyle/>
-            <a:p>
-              <a:pPr marL="0" lvl="0" indent="0" algn="ctr" defTabSz="2889250">
-                <a:lnSpc>
-                  <a:spcPct val="90000"/>
-                </a:lnSpc>
-                <a:spcBef>
-                  <a:spcPct val="0"/>
-                </a:spcBef>
-                <a:spcAft>
-                  <a:spcPct val="35000"/>
-                </a:spcAft>
-                <a:buNone/>
-              </a:pPr>
-              <a:endParaRPr lang="en-GB" sz="6500" kern="1200" dirty="0"/>
-            </a:p>
-          </p:txBody>
-        </p:sp>
-        <p:sp>
-          <p:nvSpPr>
             <p:cNvPr id="6" name="Freeform: Shape 5">
               <a:extLst>
                 <a:ext uri="{FF2B5EF4-FFF2-40B4-BE49-F238E27FC236}">
@@ -1174,8 +1343,8 @@
         </p:nvSpPr>
         <p:spPr>
           <a:xfrm>
-            <a:off x="3026229" y="1207759"/>
-            <a:ext cx="6131885" cy="5361770"/>
+            <a:off x="3026229" y="1197963"/>
+            <a:ext cx="6131885" cy="5371566"/>
           </a:xfrm>
           <a:prstGeom prst="ellipse">
             <a:avLst/>
@@ -1229,8 +1398,8 @@
         </p:nvSpPr>
         <p:spPr>
           <a:xfrm>
-            <a:off x="5425259" y="890746"/>
-            <a:ext cx="1296670" cy="754914"/>
+            <a:off x="5425259" y="889367"/>
+            <a:ext cx="1296670" cy="756293"/>
           </a:xfrm>
           <a:prstGeom prst="rect">
             <a:avLst/>
@@ -1308,8 +1477,8 @@
         </p:nvSpPr>
         <p:spPr>
           <a:xfrm>
-            <a:off x="2427199" y="3932015"/>
-            <a:ext cx="1110966" cy="957857"/>
+            <a:off x="2427199" y="3930265"/>
+            <a:ext cx="1110966" cy="959607"/>
           </a:xfrm>
           <a:prstGeom prst="rect">
             <a:avLst/>
@@ -1388,8 +1557,8 @@
         </p:nvSpPr>
         <p:spPr>
           <a:xfrm>
-            <a:off x="8714493" y="4019252"/>
-            <a:ext cx="902555" cy="979714"/>
+            <a:off x="8714493" y="4017462"/>
+            <a:ext cx="902555" cy="981504"/>
           </a:xfrm>
           <a:prstGeom prst="rect">
             <a:avLst/>
@@ -1468,8 +1637,8 @@
         </p:nvSpPr>
         <p:spPr>
           <a:xfrm rot="10966019">
-            <a:off x="9060047" y="3733148"/>
-            <a:ext cx="174247" cy="308161"/>
+            <a:off x="9060059" y="3732585"/>
+            <a:ext cx="174247" cy="308724"/>
           </a:xfrm>
           <a:prstGeom prst="triangle">
             <a:avLst>
@@ -1521,8 +1690,8 @@
         </p:nvSpPr>
         <p:spPr>
           <a:xfrm rot="19503339">
-            <a:off x="3213200" y="4871867"/>
-            <a:ext cx="157281" cy="258320"/>
+            <a:off x="3213065" y="4871438"/>
+            <a:ext cx="157281" cy="258792"/>
           </a:xfrm>
           <a:prstGeom prst="triangle">
             <a:avLst>
@@ -1574,8 +1743,8 @@
         </p:nvSpPr>
         <p:spPr>
           <a:xfrm rot="4530687">
-            <a:off x="5184180" y="1174153"/>
-            <a:ext cx="168242" cy="280752"/>
+            <a:off x="5183988" y="1174005"/>
+            <a:ext cx="168549" cy="280752"/>
           </a:xfrm>
           <a:prstGeom prst="triangle">
             <a:avLst>
@@ -1627,8 +1796,8 @@
         </p:nvSpPr>
         <p:spPr>
           <a:xfrm>
-            <a:off x="5234497" y="2166584"/>
-            <a:ext cx="1874520" cy="731520"/>
+            <a:off x="5234497" y="2165248"/>
+            <a:ext cx="1874520" cy="732856"/>
           </a:xfrm>
           <a:prstGeom prst="rect">
             <a:avLst/>
@@ -1707,8 +1876,8 @@
         </p:nvSpPr>
         <p:spPr>
           <a:xfrm>
-            <a:off x="3850945" y="4199218"/>
-            <a:ext cx="1783080" cy="749808"/>
+            <a:off x="3850945" y="4197848"/>
+            <a:ext cx="1783080" cy="751178"/>
           </a:xfrm>
           <a:prstGeom prst="rect">
             <a:avLst/>
@@ -1787,8 +1956,8 @@
         </p:nvSpPr>
         <p:spPr>
           <a:xfrm>
-            <a:off x="6548113" y="4199218"/>
-            <a:ext cx="1783080" cy="749808"/>
+            <a:off x="6548113" y="4197848"/>
+            <a:ext cx="1783080" cy="751178"/>
           </a:xfrm>
           <a:prstGeom prst="rect">
             <a:avLst/>
@@ -1867,8 +2036,8 @@
         </p:nvSpPr>
         <p:spPr>
           <a:xfrm rot="1566028">
-            <a:off x="4066058" y="3119587"/>
-            <a:ext cx="1999235" cy="575016"/>
+            <a:off x="3537871" y="2996107"/>
+            <a:ext cx="2556044" cy="576067"/>
           </a:xfrm>
           <a:prstGeom prst="rect">
             <a:avLst/>
@@ -1920,8 +2089,8 @@
         </p:nvSpPr>
         <p:spPr>
           <a:xfrm rot="19982251">
-            <a:off x="6149689" y="3258639"/>
-            <a:ext cx="1743567" cy="340548"/>
+            <a:off x="6083459" y="3099282"/>
+            <a:ext cx="2514815" cy="403134"/>
           </a:xfrm>
           <a:prstGeom prst="rect">
             <a:avLst/>
@@ -1973,8 +2142,8 @@
         </p:nvSpPr>
         <p:spPr>
           <a:xfrm rot="5400000">
-            <a:off x="5282425" y="4655541"/>
-            <a:ext cx="1644165" cy="731520"/>
+            <a:off x="5218299" y="4716667"/>
+            <a:ext cx="1772417" cy="731520"/>
           </a:xfrm>
           <a:prstGeom prst="rect">
             <a:avLst/>
@@ -2014,10 +2183,134 @@
           </a:p>
         </p:txBody>
       </p:sp>
+      <p:pic>
+        <p:nvPicPr>
+          <p:cNvPr id="1036" name="Picture 12" descr="Logo with white fill and no square">
+            <a:extLst>
+              <a:ext uri="{FF2B5EF4-FFF2-40B4-BE49-F238E27FC236}">
+                <a16:creationId xmlns:a16="http://schemas.microsoft.com/office/drawing/2014/main" id="{AE376F89-EC41-8F46-4F3E-32837FACB90E}"/>
+              </a:ext>
+            </a:extLst>
+          </p:cNvPr>
+          <p:cNvPicPr>
+            <a:picLocks noChangeAspect="1" noChangeArrowheads="1"/>
+          </p:cNvPicPr>
+          <p:nvPr/>
+        </p:nvPicPr>
+        <p:blipFill>
+          <a:blip r:embed="rId2">
+            <a:extLst>
+              <a:ext uri="{28A0092B-C50C-407E-A947-70E740481C1C}">
+                <a14:useLocalDpi xmlns:a14="http://schemas.microsoft.com/office/drawing/2010/main" val="0"/>
+              </a:ext>
+            </a:extLst>
+          </a:blip>
+          <a:srcRect/>
+          <a:stretch>
+            <a:fillRect/>
+          </a:stretch>
+        </p:blipFill>
+        <p:spPr bwMode="auto">
+          <a:xfrm>
+            <a:off x="4753078" y="2936621"/>
+            <a:ext cx="2690617" cy="1936387"/>
+          </a:xfrm>
+          <a:prstGeom prst="rect">
+            <a:avLst/>
+          </a:prstGeom>
+          <a:noFill/>
+          <a:extLst>
+            <a:ext uri="{909E8E84-426E-40DD-AFC4-6F175D3DCCD1}">
+              <a14:hiddenFill xmlns:a14="http://schemas.microsoft.com/office/drawing/2010/main">
+                <a:solidFill>
+                  <a:srgbClr val="FFFFFF"/>
+                </a:solidFill>
+              </a14:hiddenFill>
+            </a:ext>
+          </a:extLst>
+        </p:spPr>
+      </p:pic>
     </p:spTree>
     <p:extLst>
       <p:ext uri="{BB962C8B-B14F-4D97-AF65-F5344CB8AC3E}">
         <p14:creationId xmlns:p14="http://schemas.microsoft.com/office/powerpoint/2010/main" val="2747055121"/>
+      </p:ext>
+    </p:extLst>
+  </p:cSld>
+  <p:clrMapOvr>
+    <a:masterClrMapping/>
+  </p:clrMapOvr>
+</p:sld>
+</file>
+
+<file path=ppt/slides/slide2.xml><?xml version="1.0" encoding="utf-8"?>
+<p:sld xmlns:a="http://schemas.openxmlformats.org/drawingml/2006/main" xmlns:r="http://schemas.openxmlformats.org/officeDocument/2006/relationships" xmlns:p="http://schemas.openxmlformats.org/presentationml/2006/main">
+  <p:cSld>
+    <p:spTree>
+      <p:nvGrpSpPr>
+        <p:cNvPr id="1" name=""/>
+        <p:cNvGrpSpPr/>
+        <p:nvPr/>
+      </p:nvGrpSpPr>
+      <p:grpSpPr>
+        <a:xfrm>
+          <a:off x="0" y="0"/>
+          <a:ext cx="0" cy="0"/>
+          <a:chOff x="0" y="0"/>
+          <a:chExt cx="0" cy="0"/>
+        </a:xfrm>
+      </p:grpSpPr>
+      <p:pic>
+        <p:nvPicPr>
+          <p:cNvPr id="14" name="Picture 12" descr="Logo with white fill and no square">
+            <a:extLst>
+              <a:ext uri="{FF2B5EF4-FFF2-40B4-BE49-F238E27FC236}">
+                <a16:creationId xmlns:a16="http://schemas.microsoft.com/office/drawing/2014/main" id="{E2A65885-D98A-6AC5-2504-ABC5C7D55A17}"/>
+              </a:ext>
+            </a:extLst>
+          </p:cNvPr>
+          <p:cNvPicPr>
+            <a:picLocks noChangeAspect="1" noChangeArrowheads="1"/>
+          </p:cNvPicPr>
+          <p:nvPr/>
+        </p:nvPicPr>
+        <p:blipFill>
+          <a:blip r:embed="rId2">
+            <a:extLst>
+              <a:ext uri="{28A0092B-C50C-407E-A947-70E740481C1C}">
+                <a14:useLocalDpi xmlns:a14="http://schemas.microsoft.com/office/drawing/2010/main" val="0"/>
+              </a:ext>
+            </a:extLst>
+          </a:blip>
+          <a:srcRect/>
+          <a:stretch>
+            <a:fillRect/>
+          </a:stretch>
+        </p:blipFill>
+        <p:spPr bwMode="auto">
+          <a:xfrm>
+            <a:off x="4923141" y="3182584"/>
+            <a:ext cx="2666238" cy="1777492"/>
+          </a:xfrm>
+          <a:prstGeom prst="rect">
+            <a:avLst/>
+          </a:prstGeom>
+          <a:noFill/>
+          <a:extLst>
+            <a:ext uri="{909E8E84-426E-40DD-AFC4-6F175D3DCCD1}">
+              <a14:hiddenFill xmlns:a14="http://schemas.microsoft.com/office/drawing/2010/main">
+                <a:solidFill>
+                  <a:srgbClr val="FFFFFF"/>
+                </a:solidFill>
+              </a14:hiddenFill>
+            </a:ext>
+          </a:extLst>
+        </p:spPr>
+      </p:pic>
+    </p:spTree>
+    <p:extLst>
+      <p:ext uri="{BB962C8B-B14F-4D97-AF65-F5344CB8AC3E}">
+        <p14:creationId xmlns:p14="http://schemas.microsoft.com/office/powerpoint/2010/main" val="1209431417"/>
       </p:ext>
     </p:extLst>
   </p:cSld>

</xml_diff>